<commit_message>
Improve report and presentation with EDA charts
</commit_message>
<xml_diff>
--- a/presentation/Bank_Marketing_Analysis.pptx
+++ b/presentation/Bank_Marketing_Analysis.pptx
@@ -3087,6 +3087,14 @@
 <file path=ppt/slides/slide1.xml><?xml version="1.0" encoding="utf-8"?>
 <p:sld xmlns:a="http://schemas.openxmlformats.org/drawingml/2006/main" xmlns:p="http://schemas.openxmlformats.org/presentationml/2006/main" xmlns:r="http://schemas.openxmlformats.org/officeDocument/2006/relationships">
   <p:cSld>
+    <p:bg>
+      <p:bgPr>
+        <a:solidFill>
+          <a:srgbClr val="1F3750"/>
+        </a:solidFill>
+        <a:effectLst/>
+      </p:bgPr>
+    </p:bg>
     <p:spTree>
       <p:nvGrpSpPr>
         <p:cNvPr id="1" name=""/>
@@ -3096,57 +3104,14 @@
       <p:grpSpPr/>
       <p:sp>
         <p:nvSpPr>
-          <p:cNvPr id="2" name="Rectangle 1"/>
-          <p:cNvSpPr/>
+          <p:cNvPr id="2" name="TextBox 1"/>
+          <p:cNvSpPr txBox="1"/>
           <p:nvPr/>
         </p:nvSpPr>
         <p:spPr>
           <a:xfrm>
-            <a:off x="0" y="0"/>
-            <a:ext cx="12191695" cy="1143000"/>
-          </a:xfrm>
-          <a:prstGeom prst="rect">
-            <a:avLst/>
-          </a:prstGeom>
-          <a:solidFill>
-            <a:srgbClr val="1F324E"/>
-          </a:solidFill>
-          <a:ln>
-            <a:noFill/>
-          </a:ln>
-        </p:spPr>
-        <p:style>
-          <a:lnRef idx="1">
-            <a:schemeClr val="accent1"/>
-          </a:lnRef>
-          <a:fillRef idx="3">
-            <a:schemeClr val="accent1"/>
-          </a:fillRef>
-          <a:effectRef idx="2">
-            <a:schemeClr val="accent1"/>
-          </a:effectRef>
-          <a:fontRef idx="minor">
-            <a:schemeClr val="lt1"/>
-          </a:fontRef>
-        </p:style>
-        <p:txBody>
-          <a:bodyPr rtlCol="0" anchor="ctr"/>
-          <a:lstStyle/>
-          <a:p>
-            <a:pPr algn="ctr"/>
-          </a:p>
-        </p:txBody>
-      </p:sp>
-      <p:sp>
-        <p:nvSpPr>
-          <p:cNvPr id="3" name="TextBox 2"/>
-          <p:cNvSpPr txBox="1"/>
-          <p:nvPr/>
-        </p:nvSpPr>
-        <p:spPr>
-          <a:xfrm>
-            <a:off x="502920" y="228600"/>
-            <a:ext cx="11155680" cy="640080"/>
+            <a:off x="822960" y="1828800"/>
+            <a:ext cx="10515600" cy="1371600"/>
           </a:xfrm>
           <a:prstGeom prst="rect">
             <a:avLst/>
@@ -3159,29 +3124,33 @@
           </a:bodyPr>
           <a:lstStyle/>
           <a:p>
-            <a:pPr>
-              <a:defRPr sz="2700" b="1">
+            <a:pPr algn="ctr">
+              <a:defRPr sz="3400" b="1">
                 <a:solidFill>
                   <a:srgbClr val="FFFFFF"/>
                 </a:solidFill>
               </a:defRPr>
             </a:pPr>
             <a:r>
-              <a:t>Bank Marketing Campaign Analysis</a:t>
-            </a:r>
-          </a:p>
-        </p:txBody>
-      </p:sp>
-      <p:sp>
-        <p:nvSpPr>
-          <p:cNvPr id="4" name="TextBox 3"/>
+              <a:t>Bank Marketing</a:t>
+            </a:r>
+            <a:br/>
+            <a:r>
+              <a:t>Campaign Analysis</a:t>
+            </a:r>
+          </a:p>
+        </p:txBody>
+      </p:sp>
+      <p:sp>
+        <p:nvSpPr>
+          <p:cNvPr id="3" name="TextBox 2"/>
           <p:cNvSpPr txBox="1"/>
           <p:nvPr/>
         </p:nvSpPr>
         <p:spPr>
           <a:xfrm>
-            <a:off x="640080" y="1417320"/>
-            <a:ext cx="10972800" cy="548640"/>
+            <a:off x="1097280" y="3749039"/>
+            <a:ext cx="9966960" cy="731520"/>
           </a:xfrm>
           <a:prstGeom prst="rect">
             <a:avLst/>
@@ -3194,118 +3163,15 @@
           </a:bodyPr>
           <a:lstStyle/>
           <a:p>
-            <a:pPr>
-              <a:defRPr sz="1600">
-                <a:solidFill>
-                  <a:srgbClr val="3769A0"/>
+            <a:pPr algn="ctr">
+              <a:defRPr sz="1900">
+                <a:solidFill>
+                  <a:srgbClr val="FFFFFF"/>
                 </a:solidFill>
               </a:defRPr>
             </a:pPr>
             <a:r>
-              <a:t>Project Presentation</a:t>
-            </a:r>
-          </a:p>
-        </p:txBody>
-      </p:sp>
-      <p:sp>
-        <p:nvSpPr>
-          <p:cNvPr id="5" name="TextBox 4"/>
-          <p:cNvSpPr txBox="1"/>
-          <p:nvPr/>
-        </p:nvSpPr>
-        <p:spPr>
-          <a:xfrm>
-            <a:off x="731520" y="1920240"/>
-            <a:ext cx="10789920" cy="4389120"/>
-          </a:xfrm>
-          <a:prstGeom prst="rect">
-            <a:avLst/>
-          </a:prstGeom>
-          <a:noFill/>
-        </p:spPr>
-        <p:txBody>
-          <a:bodyPr wrap="square">
-            <a:spAutoFit/>
-          </a:bodyPr>
-          <a:lstStyle/>
-          <a:p>
-            <a:pPr>
-              <a:spcAft>
-                <a:spcPts val="1800"/>
-              </a:spcAft>
-              <a:defRPr sz="2100">
-                <a:solidFill>
-                  <a:srgbClr val="2D2D2D"/>
-                </a:solidFill>
-              </a:defRPr>
-            </a:pPr>
-            <a:r>
-              <a:t>Exploratory Data Analysis (EDA)</a:t>
-            </a:r>
-          </a:p>
-          <a:p>
-            <a:pPr>
-              <a:spcAft>
-                <a:spcPts val="1800"/>
-              </a:spcAft>
-              <a:defRPr sz="2100">
-                <a:solidFill>
-                  <a:srgbClr val="2D2D2D"/>
-                </a:solidFill>
-              </a:defRPr>
-            </a:pPr>
-            <a:r>
-              <a:t>Understanding customer term deposit subscriptions</a:t>
-            </a:r>
-          </a:p>
-          <a:p>
-            <a:pPr>
-              <a:spcAft>
-                <a:spcPts val="1800"/>
-              </a:spcAft>
-              <a:defRPr sz="2100">
-                <a:solidFill>
-                  <a:srgbClr val="2D2D2D"/>
-                </a:solidFill>
-              </a:defRPr>
-            </a:pPr>
-            <a:r>
-              <a:t>Tools: Python, Pandas, Matplotlib, Seaborn and Jupyter Notebook</a:t>
-            </a:r>
-          </a:p>
-        </p:txBody>
-      </p:sp>
-      <p:sp>
-        <p:nvSpPr>
-          <p:cNvPr id="6" name="TextBox 5"/>
-          <p:cNvSpPr txBox="1"/>
-          <p:nvPr/>
-        </p:nvSpPr>
-        <p:spPr>
-          <a:xfrm>
-            <a:off x="548640" y="6492240"/>
-            <a:ext cx="10972800" cy="182880"/>
-          </a:xfrm>
-          <a:prstGeom prst="rect">
-            <a:avLst/>
-          </a:prstGeom>
-          <a:noFill/>
-        </p:spPr>
-        <p:txBody>
-          <a:bodyPr wrap="none">
-            <a:spAutoFit/>
-          </a:bodyPr>
-          <a:lstStyle/>
-          <a:p>
-            <a:pPr>
-              <a:defRPr sz="900">
-                <a:solidFill>
-                  <a:srgbClr val="3769A0"/>
-                </a:solidFill>
-              </a:defRPr>
-            </a:pPr>
-            <a:r>
-              <a:t>Bank Marketing Campaign Analysis  |  Exploratory Data Analysis</a:t>
+              <a:t>Exploratory Data Analysis | Python • Pandas • Seaborn</a:t>
             </a:r>
           </a:p>
         </p:txBody>
@@ -3330,57 +3196,14 @@
       <p:grpSpPr/>
       <p:sp>
         <p:nvSpPr>
-          <p:cNvPr id="2" name="Rectangle 1"/>
-          <p:cNvSpPr/>
-          <p:nvPr/>
-        </p:nvSpPr>
-        <p:spPr>
-          <a:xfrm>
-            <a:off x="0" y="0"/>
-            <a:ext cx="12191695" cy="1143000"/>
-          </a:xfrm>
-          <a:prstGeom prst="rect">
-            <a:avLst/>
-          </a:prstGeom>
-          <a:solidFill>
-            <a:srgbClr val="1F324E"/>
-          </a:solidFill>
-          <a:ln>
-            <a:noFill/>
-          </a:ln>
-        </p:spPr>
-        <p:style>
-          <a:lnRef idx="1">
-            <a:schemeClr val="accent1"/>
-          </a:lnRef>
-          <a:fillRef idx="3">
-            <a:schemeClr val="accent1"/>
-          </a:fillRef>
-          <a:effectRef idx="2">
-            <a:schemeClr val="accent1"/>
-          </a:effectRef>
-          <a:fontRef idx="minor">
-            <a:schemeClr val="lt1"/>
-          </a:fontRef>
-        </p:style>
-        <p:txBody>
-          <a:bodyPr rtlCol="0" anchor="ctr"/>
-          <a:lstStyle/>
-          <a:p>
-            <a:pPr algn="ctr"/>
-          </a:p>
-        </p:txBody>
-      </p:sp>
-      <p:sp>
-        <p:nvSpPr>
-          <p:cNvPr id="3" name="TextBox 2"/>
+          <p:cNvPr id="2" name="TextBox 1"/>
           <p:cNvSpPr txBox="1"/>
           <p:nvPr/>
         </p:nvSpPr>
         <p:spPr>
           <a:xfrm>
             <a:off x="502920" y="228600"/>
-            <a:ext cx="11155680" cy="640080"/>
+            <a:ext cx="11155680" cy="594360"/>
           </a:xfrm>
           <a:prstGeom prst="rect">
             <a:avLst/>
@@ -3396,26 +3219,26 @@
             <a:pPr>
               <a:defRPr sz="2700" b="1">
                 <a:solidFill>
-                  <a:srgbClr val="FFFFFF"/>
+                  <a:srgbClr val="1F3750"/>
                 </a:solidFill>
               </a:defRPr>
             </a:pPr>
             <a:r>
-              <a:t>Project Objective</a:t>
-            </a:r>
-          </a:p>
-        </p:txBody>
-      </p:sp>
-      <p:sp>
-        <p:nvSpPr>
-          <p:cNvPr id="4" name="TextBox 3"/>
+              <a:t>Project Objective &amp; Dataset</a:t>
+            </a:r>
+          </a:p>
+        </p:txBody>
+      </p:sp>
+      <p:sp>
+        <p:nvSpPr>
+          <p:cNvPr id="3" name="TextBox 2"/>
           <p:cNvSpPr txBox="1"/>
           <p:nvPr/>
         </p:nvSpPr>
         <p:spPr>
           <a:xfrm>
-            <a:off x="731520" y="1645920"/>
-            <a:ext cx="10789920" cy="4389120"/>
+            <a:off x="731520" y="1371600"/>
+            <a:ext cx="10789920" cy="4846320"/>
           </a:xfrm>
           <a:prstGeom prst="rect">
             <a:avLst/>
@@ -3430,96 +3253,76 @@
           <a:p>
             <a:pPr>
               <a:spcAft>
-                <a:spcPts val="1800"/>
+                <a:spcPts val="1700"/>
               </a:spcAft>
-              <a:defRPr sz="2100">
+              <a:defRPr sz="2000">
                 <a:solidFill>
                   <a:srgbClr val="2D2D2D"/>
                 </a:solidFill>
               </a:defRPr>
             </a:pPr>
             <a:r>
-              <a:t>Explore customer demographics and marketing campaign information.</a:t>
+              <a:t>Objective: explore factors associated with term deposit subscriptions.</a:t>
             </a:r>
           </a:p>
           <a:p>
             <a:pPr>
               <a:spcAft>
-                <a:spcPts val="1800"/>
+                <a:spcPts val="1700"/>
               </a:spcAft>
-              <a:defRPr sz="2100">
+              <a:defRPr sz="2000">
                 <a:solidFill>
                   <a:srgbClr val="2D2D2D"/>
                 </a:solidFill>
               </a:defRPr>
             </a:pPr>
             <a:r>
-              <a:t>Measure subscription rates across customer groups.</a:t>
+              <a:t>Dataset: 41,188 customer records and 21 columns.</a:t>
             </a:r>
           </a:p>
           <a:p>
             <a:pPr>
               <a:spcAft>
-                <a:spcPts val="1800"/>
+                <a:spcPts val="1700"/>
               </a:spcAft>
-              <a:defRPr sz="2100">
+              <a:defRPr sz="2000">
                 <a:solidFill>
                   <a:srgbClr val="2D2D2D"/>
                 </a:solidFill>
               </a:defRPr>
             </a:pPr>
             <a:r>
-              <a:t>Compare contact methods, previous campaign outcomes and campaign timing.</a:t>
+              <a:t>Subscribed: 4,640 customers (11.27%).</a:t>
             </a:r>
           </a:p>
           <a:p>
             <a:pPr>
               <a:spcAft>
-                <a:spcPts val="1800"/>
+                <a:spcPts val="1700"/>
               </a:spcAft>
-              <a:defRPr sz="2100">
+              <a:defRPr sz="2000">
                 <a:solidFill>
                   <a:srgbClr val="2D2D2D"/>
                 </a:solidFill>
               </a:defRPr>
             </a:pPr>
             <a:r>
-              <a:t>Identify patterns that may support better campaign planning.</a:t>
-            </a:r>
-          </a:p>
-        </p:txBody>
-      </p:sp>
-      <p:sp>
-        <p:nvSpPr>
-          <p:cNvPr id="5" name="TextBox 4"/>
-          <p:cNvSpPr txBox="1"/>
-          <p:nvPr/>
-        </p:nvSpPr>
-        <p:spPr>
-          <a:xfrm>
-            <a:off x="548640" y="6492240"/>
-            <a:ext cx="10972800" cy="182880"/>
-          </a:xfrm>
-          <a:prstGeom prst="rect">
-            <a:avLst/>
-          </a:prstGeom>
-          <a:noFill/>
-        </p:spPr>
-        <p:txBody>
-          <a:bodyPr wrap="none">
-            <a:spAutoFit/>
-          </a:bodyPr>
-          <a:lstStyle/>
+              <a:t>Not subscribed: 36,548 customers (88.73%).</a:t>
+            </a:r>
+          </a:p>
           <a:p>
             <a:pPr>
-              <a:defRPr sz="900">
-                <a:solidFill>
-                  <a:srgbClr val="3769A0"/>
+              <a:spcAft>
+                <a:spcPts val="1700"/>
+              </a:spcAft>
+              <a:defRPr sz="2000">
+                <a:solidFill>
+                  <a:srgbClr val="2D2D2D"/>
                 </a:solidFill>
               </a:defRPr>
             </a:pPr>
             <a:r>
-              <a:t>Bank Marketing Campaign Analysis  |  Exploratory Data Analysis</a:t>
+              <a:t>Methods: data quality checks, group comparisons and visualizations.</a:t>
             </a:r>
           </a:p>
         </p:txBody>
@@ -3544,57 +3347,14 @@
       <p:grpSpPr/>
       <p:sp>
         <p:nvSpPr>
-          <p:cNvPr id="2" name="Rectangle 1"/>
-          <p:cNvSpPr/>
-          <p:nvPr/>
-        </p:nvSpPr>
-        <p:spPr>
-          <a:xfrm>
-            <a:off x="0" y="0"/>
-            <a:ext cx="12191695" cy="1143000"/>
-          </a:xfrm>
-          <a:prstGeom prst="rect">
-            <a:avLst/>
-          </a:prstGeom>
-          <a:solidFill>
-            <a:srgbClr val="1F324E"/>
-          </a:solidFill>
-          <a:ln>
-            <a:noFill/>
-          </a:ln>
-        </p:spPr>
-        <p:style>
-          <a:lnRef idx="1">
-            <a:schemeClr val="accent1"/>
-          </a:lnRef>
-          <a:fillRef idx="3">
-            <a:schemeClr val="accent1"/>
-          </a:fillRef>
-          <a:effectRef idx="2">
-            <a:schemeClr val="accent1"/>
-          </a:effectRef>
-          <a:fontRef idx="minor">
-            <a:schemeClr val="lt1"/>
-          </a:fontRef>
-        </p:style>
-        <p:txBody>
-          <a:bodyPr rtlCol="0" anchor="ctr"/>
-          <a:lstStyle/>
-          <a:p>
-            <a:pPr algn="ctr"/>
-          </a:p>
-        </p:txBody>
-      </p:sp>
-      <p:sp>
-        <p:nvSpPr>
-          <p:cNvPr id="3" name="TextBox 2"/>
+          <p:cNvPr id="2" name="TextBox 1"/>
           <p:cNvSpPr txBox="1"/>
           <p:nvPr/>
         </p:nvSpPr>
         <p:spPr>
           <a:xfrm>
             <a:off x="502920" y="228600"/>
-            <a:ext cx="11155680" cy="640080"/>
+            <a:ext cx="11155680" cy="594360"/>
           </a:xfrm>
           <a:prstGeom prst="rect">
             <a:avLst/>
@@ -3610,16 +3370,40 @@
             <a:pPr>
               <a:defRPr sz="2700" b="1">
                 <a:solidFill>
-                  <a:srgbClr val="FFFFFF"/>
+                  <a:srgbClr val="1F3750"/>
                 </a:solidFill>
               </a:defRPr>
             </a:pPr>
             <a:r>
-              <a:t>Dataset Overview</a:t>
-            </a:r>
-          </a:p>
-        </p:txBody>
-      </p:sp>
+              <a:t>Subscription Distribution</a:t>
+            </a:r>
+          </a:p>
+        </p:txBody>
+      </p:sp>
+      <p:pic>
+        <p:nvPicPr>
+          <p:cNvPr id="3" name="Picture 2" descr="subscription_distribution.png"/>
+          <p:cNvPicPr>
+            <a:picLocks noChangeAspect="1"/>
+          </p:cNvPicPr>
+          <p:nvPr/>
+        </p:nvPicPr>
+        <p:blipFill>
+          <a:blip r:embed="rId2"/>
+          <a:stretch>
+            <a:fillRect/>
+          </a:stretch>
+        </p:blipFill>
+        <p:spPr>
+          <a:xfrm>
+            <a:off x="685800" y="1051560"/>
+            <a:ext cx="6858000" cy="4220308"/>
+          </a:xfrm>
+          <a:prstGeom prst="rect">
+            <a:avLst/>
+          </a:prstGeom>
+        </p:spPr>
+      </p:pic>
       <p:sp>
         <p:nvSpPr>
           <p:cNvPr id="4" name="TextBox 3"/>
@@ -3628,8 +3412,8 @@
         </p:nvSpPr>
         <p:spPr>
           <a:xfrm>
-            <a:off x="731520" y="1645920"/>
-            <a:ext cx="10789920" cy="4389120"/>
+            <a:off x="7818120" y="1554480"/>
+            <a:ext cx="3749039" cy="4114800"/>
           </a:xfrm>
           <a:prstGeom prst="rect">
             <a:avLst/>
@@ -3643,127 +3427,29 @@
           <a:lstStyle/>
           <a:p>
             <a:pPr>
-              <a:spcAft>
-                <a:spcPts val="1800"/>
-              </a:spcAft>
-              <a:defRPr sz="2100">
+              <a:defRPr sz="2200" b="1">
+                <a:solidFill>
+                  <a:srgbClr val="31689D"/>
+                </a:solidFill>
+              </a:defRPr>
+            </a:pPr>
+            <a:r>
+              <a:t>Key takeaway</a:t>
+            </a:r>
+          </a:p>
+          <a:p>
+            <a:pPr>
+              <a:spcBef>
+                <a:spcPts val="1400"/>
+              </a:spcBef>
+              <a:defRPr sz="1800">
                 <a:solidFill>
                   <a:srgbClr val="2D2D2D"/>
                 </a:solidFill>
               </a:defRPr>
             </a:pPr>
             <a:r>
-              <a:t>Records: 41,188</a:t>
-            </a:r>
-          </a:p>
-          <a:p>
-            <a:pPr>
-              <a:spcAft>
-                <a:spcPts val="1800"/>
-              </a:spcAft>
-              <a:defRPr sz="2100">
-                <a:solidFill>
-                  <a:srgbClr val="2D2D2D"/>
-                </a:solidFill>
-              </a:defRPr>
-            </a:pPr>
-            <a:r>
-              <a:t>Variables: 22</a:t>
-            </a:r>
-          </a:p>
-          <a:p>
-            <a:pPr>
-              <a:spcAft>
-                <a:spcPts val="1800"/>
-              </a:spcAft>
-              <a:defRPr sz="2100">
-                <a:solidFill>
-                  <a:srgbClr val="2D2D2D"/>
-                </a:solidFill>
-              </a:defRPr>
-            </a:pPr>
-            <a:r>
-              <a:t>Subscriptions: 4,640</a:t>
-            </a:r>
-          </a:p>
-          <a:p>
-            <a:pPr>
-              <a:spcAft>
-                <a:spcPts val="1800"/>
-              </a:spcAft>
-              <a:defRPr sz="2100">
-                <a:solidFill>
-                  <a:srgbClr val="2D2D2D"/>
-                </a:solidFill>
-              </a:defRPr>
-            </a:pPr>
-            <a:r>
-              <a:t>Non-subscriptions: 36,548</a:t>
-            </a:r>
-          </a:p>
-          <a:p>
-            <a:pPr>
-              <a:spcAft>
-                <a:spcPts val="1800"/>
-              </a:spcAft>
-              <a:defRPr sz="2100">
-                <a:solidFill>
-                  <a:srgbClr val="2D2D2D"/>
-                </a:solidFill>
-              </a:defRPr>
-            </a:pPr>
-            <a:r>
-              <a:t>Overall subscription rate: 11.27%</a:t>
-            </a:r>
-          </a:p>
-          <a:p>
-            <a:pPr>
-              <a:spcAft>
-                <a:spcPts val="1800"/>
-              </a:spcAft>
-              <a:defRPr sz="2100">
-                <a:solidFill>
-                  <a:srgbClr val="2D2D2D"/>
-                </a:solidFill>
-              </a:defRPr>
-            </a:pPr>
-            <a:r>
-              <a:t>Source: UCI Machine Learning Repository — Bank Marketing dataset</a:t>
-            </a:r>
-          </a:p>
-        </p:txBody>
-      </p:sp>
-      <p:sp>
-        <p:nvSpPr>
-          <p:cNvPr id="5" name="TextBox 4"/>
-          <p:cNvSpPr txBox="1"/>
-          <p:nvPr/>
-        </p:nvSpPr>
-        <p:spPr>
-          <a:xfrm>
-            <a:off x="548640" y="6492240"/>
-            <a:ext cx="10972800" cy="182880"/>
-          </a:xfrm>
-          <a:prstGeom prst="rect">
-            <a:avLst/>
-          </a:prstGeom>
-          <a:noFill/>
-        </p:spPr>
-        <p:txBody>
-          <a:bodyPr wrap="none">
-            <a:spAutoFit/>
-          </a:bodyPr>
-          <a:lstStyle/>
-          <a:p>
-            <a:pPr>
-              <a:defRPr sz="900">
-                <a:solidFill>
-                  <a:srgbClr val="3769A0"/>
-                </a:solidFill>
-              </a:defRPr>
-            </a:pPr>
-            <a:r>
-              <a:t>Bank Marketing Campaign Analysis  |  Exploratory Data Analysis</a:t>
+              <a:t>Only 11.27% of records resulted in a subscription. The target is imbalanced, so comparing percentages is more informative than relying only on raw counts.</a:t>
             </a:r>
           </a:p>
         </p:txBody>
@@ -3788,57 +3474,14 @@
       <p:grpSpPr/>
       <p:sp>
         <p:nvSpPr>
-          <p:cNvPr id="2" name="Rectangle 1"/>
-          <p:cNvSpPr/>
-          <p:nvPr/>
-        </p:nvSpPr>
-        <p:spPr>
-          <a:xfrm>
-            <a:off x="0" y="0"/>
-            <a:ext cx="12191695" cy="1143000"/>
-          </a:xfrm>
-          <a:prstGeom prst="rect">
-            <a:avLst/>
-          </a:prstGeom>
-          <a:solidFill>
-            <a:srgbClr val="1F324E"/>
-          </a:solidFill>
-          <a:ln>
-            <a:noFill/>
-          </a:ln>
-        </p:spPr>
-        <p:style>
-          <a:lnRef idx="1">
-            <a:schemeClr val="accent1"/>
-          </a:lnRef>
-          <a:fillRef idx="3">
-            <a:schemeClr val="accent1"/>
-          </a:fillRef>
-          <a:effectRef idx="2">
-            <a:schemeClr val="accent1"/>
-          </a:effectRef>
-          <a:fontRef idx="minor">
-            <a:schemeClr val="lt1"/>
-          </a:fontRef>
-        </p:style>
-        <p:txBody>
-          <a:bodyPr rtlCol="0" anchor="ctr"/>
-          <a:lstStyle/>
-          <a:p>
-            <a:pPr algn="ctr"/>
-          </a:p>
-        </p:txBody>
-      </p:sp>
-      <p:sp>
-        <p:nvSpPr>
-          <p:cNvPr id="3" name="TextBox 2"/>
+          <p:cNvPr id="2" name="TextBox 1"/>
           <p:cNvSpPr txBox="1"/>
           <p:nvPr/>
         </p:nvSpPr>
         <p:spPr>
           <a:xfrm>
             <a:off x="502920" y="228600"/>
-            <a:ext cx="11155680" cy="640080"/>
+            <a:ext cx="11155680" cy="594360"/>
           </a:xfrm>
           <a:prstGeom prst="rect">
             <a:avLst/>
@@ -3854,16 +3497,40 @@
             <a:pPr>
               <a:defRPr sz="2700" b="1">
                 <a:solidFill>
-                  <a:srgbClr val="FFFFFF"/>
+                  <a:srgbClr val="1F3750"/>
                 </a:solidFill>
               </a:defRPr>
             </a:pPr>
             <a:r>
-              <a:t>Exploratory Analysis</a:t>
-            </a:r>
-          </a:p>
-        </p:txBody>
-      </p:sp>
+              <a:t>Subscription Rate by Contact Method</a:t>
+            </a:r>
+          </a:p>
+        </p:txBody>
+      </p:sp>
+      <p:pic>
+        <p:nvPicPr>
+          <p:cNvPr id="3" name="Picture 2" descr="subscription_by_contact.png"/>
+          <p:cNvPicPr>
+            <a:picLocks noChangeAspect="1"/>
+          </p:cNvPicPr>
+          <p:nvPr/>
+        </p:nvPicPr>
+        <p:blipFill>
+          <a:blip r:embed="rId2"/>
+          <a:stretch>
+            <a:fillRect/>
+          </a:stretch>
+        </p:blipFill>
+        <p:spPr>
+          <a:xfrm>
+            <a:off x="685800" y="1051560"/>
+            <a:ext cx="6858000" cy="4228372"/>
+          </a:xfrm>
+          <a:prstGeom prst="rect">
+            <a:avLst/>
+          </a:prstGeom>
+        </p:spPr>
+      </p:pic>
       <p:sp>
         <p:nvSpPr>
           <p:cNvPr id="4" name="TextBox 3"/>
@@ -3872,8 +3539,8 @@
         </p:nvSpPr>
         <p:spPr>
           <a:xfrm>
-            <a:off x="731520" y="1645920"/>
-            <a:ext cx="10789920" cy="4389120"/>
+            <a:off x="7818120" y="1554480"/>
+            <a:ext cx="3749039" cy="4114800"/>
           </a:xfrm>
           <a:prstGeom prst="rect">
             <a:avLst/>
@@ -3887,97 +3554,29 @@
           <a:lstStyle/>
           <a:p>
             <a:pPr>
-              <a:spcAft>
-                <a:spcPts val="1800"/>
-              </a:spcAft>
-              <a:defRPr sz="2100">
+              <a:defRPr sz="2200" b="1">
+                <a:solidFill>
+                  <a:srgbClr val="31689D"/>
+                </a:solidFill>
+              </a:defRPr>
+            </a:pPr>
+            <a:r>
+              <a:t>Key takeaway</a:t>
+            </a:r>
+          </a:p>
+          <a:p>
+            <a:pPr>
+              <a:spcBef>
+                <a:spcPts val="1400"/>
+              </a:spcBef>
+              <a:defRPr sz="1800">
                 <a:solidFill>
                   <a:srgbClr val="2D2D2D"/>
                 </a:solidFill>
               </a:defRPr>
             </a:pPr>
             <a:r>
-              <a:t>Reviewed dataset structure, data types and descriptive statistics.</a:t>
-            </a:r>
-          </a:p>
-          <a:p>
-            <a:pPr>
-              <a:spcAft>
-                <a:spcPts val="1800"/>
-              </a:spcAft>
-              <a:defRPr sz="2100">
-                <a:solidFill>
-                  <a:srgbClr val="2D2D2D"/>
-                </a:solidFill>
-              </a:defRPr>
-            </a:pPr>
-            <a:r>
-              <a:t>Checked actual missing values, unknown categories and duplicate rows.</a:t>
-            </a:r>
-          </a:p>
-          <a:p>
-            <a:pPr>
-              <a:spcAft>
-                <a:spcPts val="1800"/>
-              </a:spcAft>
-              <a:defRPr sz="2100">
-                <a:solidFill>
-                  <a:srgbClr val="2D2D2D"/>
-                </a:solidFill>
-              </a:defRPr>
-            </a:pPr>
-            <a:r>
-              <a:t>Compared subscription rates by job category and age group.</a:t>
-            </a:r>
-          </a:p>
-          <a:p>
-            <a:pPr>
-              <a:spcAft>
-                <a:spcPts val="1800"/>
-              </a:spcAft>
-              <a:defRPr sz="2100">
-                <a:solidFill>
-                  <a:srgbClr val="2D2D2D"/>
-                </a:solidFill>
-              </a:defRPr>
-            </a:pPr>
-            <a:r>
-              <a:t>Examined contact method, previous campaign outcome and campaign month.</a:t>
-            </a:r>
-          </a:p>
-        </p:txBody>
-      </p:sp>
-      <p:sp>
-        <p:nvSpPr>
-          <p:cNvPr id="5" name="TextBox 4"/>
-          <p:cNvSpPr txBox="1"/>
-          <p:nvPr/>
-        </p:nvSpPr>
-        <p:spPr>
-          <a:xfrm>
-            <a:off x="548640" y="6492240"/>
-            <a:ext cx="10972800" cy="182880"/>
-          </a:xfrm>
-          <a:prstGeom prst="rect">
-            <a:avLst/>
-          </a:prstGeom>
-          <a:noFill/>
-        </p:spPr>
-        <p:txBody>
-          <a:bodyPr wrap="none">
-            <a:spAutoFit/>
-          </a:bodyPr>
-          <a:lstStyle/>
-          <a:p>
-            <a:pPr>
-              <a:defRPr sz="900">
-                <a:solidFill>
-                  <a:srgbClr val="3769A0"/>
-                </a:solidFill>
-              </a:defRPr>
-            </a:pPr>
-            <a:r>
-              <a:t>Bank Marketing Campaign Analysis  |  Exploratory Data Analysis</a:t>
+              <a:t>Observed rates differ by contact method. cellular: 14.74%; telephone: 5.23%. This is an association, not proof that contact method alone caused the difference.</a:t>
             </a:r>
           </a:p>
         </p:txBody>
@@ -4002,57 +3601,14 @@
       <p:grpSpPr/>
       <p:sp>
         <p:nvSpPr>
-          <p:cNvPr id="2" name="Rectangle 1"/>
-          <p:cNvSpPr/>
-          <p:nvPr/>
-        </p:nvSpPr>
-        <p:spPr>
-          <a:xfrm>
-            <a:off x="0" y="0"/>
-            <a:ext cx="12191695" cy="1143000"/>
-          </a:xfrm>
-          <a:prstGeom prst="rect">
-            <a:avLst/>
-          </a:prstGeom>
-          <a:solidFill>
-            <a:srgbClr val="1F324E"/>
-          </a:solidFill>
-          <a:ln>
-            <a:noFill/>
-          </a:ln>
-        </p:spPr>
-        <p:style>
-          <a:lnRef idx="1">
-            <a:schemeClr val="accent1"/>
-          </a:lnRef>
-          <a:fillRef idx="3">
-            <a:schemeClr val="accent1"/>
-          </a:fillRef>
-          <a:effectRef idx="2">
-            <a:schemeClr val="accent1"/>
-          </a:effectRef>
-          <a:fontRef idx="minor">
-            <a:schemeClr val="lt1"/>
-          </a:fontRef>
-        </p:style>
-        <p:txBody>
-          <a:bodyPr rtlCol="0" anchor="ctr"/>
-          <a:lstStyle/>
-          <a:p>
-            <a:pPr algn="ctr"/>
-          </a:p>
-        </p:txBody>
-      </p:sp>
-      <p:sp>
-        <p:nvSpPr>
-          <p:cNvPr id="3" name="TextBox 2"/>
+          <p:cNvPr id="2" name="TextBox 1"/>
           <p:cNvSpPr txBox="1"/>
           <p:nvPr/>
         </p:nvSpPr>
         <p:spPr>
           <a:xfrm>
             <a:off x="502920" y="228600"/>
-            <a:ext cx="11155680" cy="640080"/>
+            <a:ext cx="11155680" cy="594360"/>
           </a:xfrm>
           <a:prstGeom prst="rect">
             <a:avLst/>
@@ -4068,16 +3624,40 @@
             <a:pPr>
               <a:defRPr sz="2700" b="1">
                 <a:solidFill>
-                  <a:srgbClr val="FFFFFF"/>
+                  <a:srgbClr val="1F3750"/>
                 </a:solidFill>
               </a:defRPr>
             </a:pPr>
             <a:r>
-              <a:t>Campaign Response Patterns</a:t>
-            </a:r>
-          </a:p>
-        </p:txBody>
-      </p:sp>
+              <a:t>Previous Campaign Outcome</a:t>
+            </a:r>
+          </a:p>
+        </p:txBody>
+      </p:sp>
+      <p:pic>
+        <p:nvPicPr>
+          <p:cNvPr id="3" name="Picture 2" descr="subscription_by_previous_outcome.png"/>
+          <p:cNvPicPr>
+            <a:picLocks noChangeAspect="1"/>
+          </p:cNvPicPr>
+          <p:nvPr/>
+        </p:nvPicPr>
+        <p:blipFill>
+          <a:blip r:embed="rId2"/>
+          <a:stretch>
+            <a:fillRect/>
+          </a:stretch>
+        </p:blipFill>
+        <p:spPr>
+          <a:xfrm>
+            <a:off x="685800" y="1051560"/>
+            <a:ext cx="6858000" cy="4228372"/>
+          </a:xfrm>
+          <a:prstGeom prst="rect">
+            <a:avLst/>
+          </a:prstGeom>
+        </p:spPr>
+      </p:pic>
       <p:sp>
         <p:nvSpPr>
           <p:cNvPr id="4" name="TextBox 3"/>
@@ -4086,8 +3666,8 @@
         </p:nvSpPr>
         <p:spPr>
           <a:xfrm>
-            <a:off x="731520" y="1645920"/>
-            <a:ext cx="10789920" cy="4389120"/>
+            <a:off x="7818120" y="1554480"/>
+            <a:ext cx="3749039" cy="4114800"/>
           </a:xfrm>
           <a:prstGeom prst="rect">
             <a:avLst/>
@@ -4101,97 +3681,29 @@
           <a:lstStyle/>
           <a:p>
             <a:pPr>
-              <a:spcAft>
-                <a:spcPts val="1800"/>
-              </a:spcAft>
-              <a:defRPr sz="2100">
+              <a:defRPr sz="2200" b="1">
+                <a:solidFill>
+                  <a:srgbClr val="31689D"/>
+                </a:solidFill>
+              </a:defRPr>
+            </a:pPr>
+            <a:r>
+              <a:t>Key takeaway</a:t>
+            </a:r>
+          </a:p>
+          <a:p>
+            <a:pPr>
+              <a:spcBef>
+                <a:spcPts val="1400"/>
+              </a:spcBef>
+              <a:defRPr sz="1800">
                 <a:solidFill>
                   <a:srgbClr val="2D2D2D"/>
                 </a:solidFill>
               </a:defRPr>
             </a:pPr>
             <a:r>
-              <a:t>Subscription rates can differ across customer groups.</a:t>
-            </a:r>
-          </a:p>
-          <a:p>
-            <a:pPr>
-              <a:spcAft>
-                <a:spcPts val="1800"/>
-              </a:spcAft>
-              <a:defRPr sz="2100">
-                <a:solidFill>
-                  <a:srgbClr val="2D2D2D"/>
-                </a:solidFill>
-              </a:defRPr>
-            </a:pPr>
-            <a:r>
-              <a:t>Previous campaign outcomes may be associated with current responses.</a:t>
-            </a:r>
-          </a:p>
-          <a:p>
-            <a:pPr>
-              <a:spcAft>
-                <a:spcPts val="1800"/>
-              </a:spcAft>
-              <a:defRPr sz="2100">
-                <a:solidFill>
-                  <a:srgbClr val="2D2D2D"/>
-                </a:solidFill>
-              </a:defRPr>
-            </a:pPr>
-            <a:r>
-              <a:t>Contact frequency should be assessed using both customer counts and rates.</a:t>
-            </a:r>
-          </a:p>
-          <a:p>
-            <a:pPr>
-              <a:spcAft>
-                <a:spcPts val="1800"/>
-              </a:spcAft>
-              <a:defRPr sz="2100">
-                <a:solidFill>
-                  <a:srgbClr val="2D2D2D"/>
-                </a:solidFill>
-              </a:defRPr>
-            </a:pPr>
-            <a:r>
-              <a:t>Monthly response rates can vary with campaign volume and timing.</a:t>
-            </a:r>
-          </a:p>
-        </p:txBody>
-      </p:sp>
-      <p:sp>
-        <p:nvSpPr>
-          <p:cNvPr id="5" name="TextBox 4"/>
-          <p:cNvSpPr txBox="1"/>
-          <p:nvPr/>
-        </p:nvSpPr>
-        <p:spPr>
-          <a:xfrm>
-            <a:off x="548640" y="6492240"/>
-            <a:ext cx="10972800" cy="182880"/>
-          </a:xfrm>
-          <a:prstGeom prst="rect">
-            <a:avLst/>
-          </a:prstGeom>
-          <a:noFill/>
-        </p:spPr>
-        <p:txBody>
-          <a:bodyPr wrap="none">
-            <a:spAutoFit/>
-          </a:bodyPr>
-          <a:lstStyle/>
-          <a:p>
-            <a:pPr>
-              <a:defRPr sz="900">
-                <a:solidFill>
-                  <a:srgbClr val="3769A0"/>
-                </a:solidFill>
-              </a:defRPr>
-            </a:pPr>
-            <a:r>
-              <a:t>Bank Marketing Campaign Analysis  |  Exploratory Data Analysis</a:t>
+              <a:t>Subscription rates vary with the recorded previous campaign outcome. success: 65.11%; failure: 14.23%; nonexistent: 8.83%. Group sizes and other customer characteristics also matter.</a:t>
             </a:r>
           </a:p>
         </p:txBody>
@@ -4216,57 +3728,14 @@
       <p:grpSpPr/>
       <p:sp>
         <p:nvSpPr>
-          <p:cNvPr id="2" name="Rectangle 1"/>
-          <p:cNvSpPr/>
-          <p:nvPr/>
-        </p:nvSpPr>
-        <p:spPr>
-          <a:xfrm>
-            <a:off x="0" y="0"/>
-            <a:ext cx="12191695" cy="1143000"/>
-          </a:xfrm>
-          <a:prstGeom prst="rect">
-            <a:avLst/>
-          </a:prstGeom>
-          <a:solidFill>
-            <a:srgbClr val="1F324E"/>
-          </a:solidFill>
-          <a:ln>
-            <a:noFill/>
-          </a:ln>
-        </p:spPr>
-        <p:style>
-          <a:lnRef idx="1">
-            <a:schemeClr val="accent1"/>
-          </a:lnRef>
-          <a:fillRef idx="3">
-            <a:schemeClr val="accent1"/>
-          </a:fillRef>
-          <a:effectRef idx="2">
-            <a:schemeClr val="accent1"/>
-          </a:effectRef>
-          <a:fontRef idx="minor">
-            <a:schemeClr val="lt1"/>
-          </a:fontRef>
-        </p:style>
-        <p:txBody>
-          <a:bodyPr rtlCol="0" anchor="ctr"/>
-          <a:lstStyle/>
-          <a:p>
-            <a:pPr algn="ctr"/>
-          </a:p>
-        </p:txBody>
-      </p:sp>
-      <p:sp>
-        <p:nvSpPr>
-          <p:cNvPr id="3" name="TextBox 2"/>
+          <p:cNvPr id="2" name="TextBox 1"/>
           <p:cNvSpPr txBox="1"/>
           <p:nvPr/>
         </p:nvSpPr>
         <p:spPr>
           <a:xfrm>
             <a:off x="502920" y="228600"/>
-            <a:ext cx="11155680" cy="640080"/>
+            <a:ext cx="11155680" cy="594360"/>
           </a:xfrm>
           <a:prstGeom prst="rect">
             <a:avLst/>
@@ -4282,26 +3751,26 @@
             <a:pPr>
               <a:defRPr sz="2700" b="1">
                 <a:solidFill>
-                  <a:srgbClr val="FFFFFF"/>
+                  <a:srgbClr val="1F3750"/>
                 </a:solidFill>
               </a:defRPr>
             </a:pPr>
             <a:r>
-              <a:t>Limitations and Considerations</a:t>
-            </a:r>
-          </a:p>
-        </p:txBody>
-      </p:sp>
-      <p:sp>
-        <p:nvSpPr>
-          <p:cNvPr id="4" name="TextBox 3"/>
+              <a:t>Additional Patterns</a:t>
+            </a:r>
+          </a:p>
+        </p:txBody>
+      </p:sp>
+      <p:sp>
+        <p:nvSpPr>
+          <p:cNvPr id="3" name="TextBox 2"/>
           <p:cNvSpPr txBox="1"/>
           <p:nvPr/>
         </p:nvSpPr>
         <p:spPr>
           <a:xfrm>
-            <a:off x="731520" y="1645920"/>
-            <a:ext cx="10789920" cy="4389120"/>
+            <a:off x="731520" y="1371600"/>
+            <a:ext cx="10789920" cy="4846320"/>
           </a:xfrm>
           <a:prstGeom prst="rect">
             <a:avLst/>
@@ -4316,96 +3785,76 @@
           <a:p>
             <a:pPr>
               <a:spcAft>
-                <a:spcPts val="1800"/>
+                <a:spcPts val="1700"/>
               </a:spcAft>
-              <a:defRPr sz="2100">
+              <a:defRPr sz="1900">
                 <a:solidFill>
                   <a:srgbClr val="2D2D2D"/>
                 </a:solidFill>
               </a:defRPr>
             </a:pPr>
             <a:r>
-              <a:t>The analysis describes associations; it does not prove causation.</a:t>
+              <a:t>Job categories with the highest observed subscription rates:</a:t>
             </a:r>
           </a:p>
           <a:p>
             <a:pPr>
               <a:spcAft>
-                <a:spcPts val="1800"/>
+                <a:spcPts val="1700"/>
               </a:spcAft>
-              <a:defRPr sz="2100">
+              <a:defRPr sz="1900">
                 <a:solidFill>
                   <a:srgbClr val="2D2D2D"/>
                 </a:solidFill>
               </a:defRPr>
             </a:pPr>
             <a:r>
-              <a:t>Unknown categories may affect interpretation of customer characteristics.</a:t>
+              <a:t>student: 31.43%; retired: 25.23%; unemployed: 14.20%</a:t>
             </a:r>
           </a:p>
           <a:p>
             <a:pPr>
               <a:spcAft>
-                <a:spcPts val="1800"/>
+                <a:spcPts val="1700"/>
               </a:spcAft>
-              <a:defRPr sz="2100">
+              <a:defRPr sz="1900">
                 <a:solidFill>
                   <a:srgbClr val="2D2D2D"/>
                 </a:solidFill>
               </a:defRPr>
             </a:pPr>
             <a:r>
-              <a:t>Campaign results may depend on the historical period and economic context.</a:t>
+              <a:t>Months with the highest observed subscription rates:</a:t>
             </a:r>
           </a:p>
           <a:p>
             <a:pPr>
               <a:spcAft>
-                <a:spcPts val="1800"/>
+                <a:spcPts val="1700"/>
               </a:spcAft>
-              <a:defRPr sz="2100">
+              <a:defRPr sz="1900">
                 <a:solidFill>
                   <a:srgbClr val="2D2D2D"/>
                 </a:solidFill>
               </a:defRPr>
             </a:pPr>
             <a:r>
-              <a:t>Call duration is known after the call and should not be used for pre-call targeting.</a:t>
-            </a:r>
-          </a:p>
-        </p:txBody>
-      </p:sp>
-      <p:sp>
-        <p:nvSpPr>
-          <p:cNvPr id="5" name="TextBox 4"/>
-          <p:cNvSpPr txBox="1"/>
-          <p:nvPr/>
-        </p:nvSpPr>
-        <p:spPr>
-          <a:xfrm>
-            <a:off x="548640" y="6492240"/>
-            <a:ext cx="10972800" cy="182880"/>
-          </a:xfrm>
-          <a:prstGeom prst="rect">
-            <a:avLst/>
-          </a:prstGeom>
-          <a:noFill/>
-        </p:spPr>
-        <p:txBody>
-          <a:bodyPr wrap="none">
-            <a:spAutoFit/>
-          </a:bodyPr>
-          <a:lstStyle/>
+              <a:t>mar: 50.55%; dec: 48.90%; sep: 44.91%</a:t>
+            </a:r>
+          </a:p>
           <a:p>
             <a:pPr>
-              <a:defRPr sz="900">
-                <a:solidFill>
-                  <a:srgbClr val="3769A0"/>
+              <a:spcAft>
+                <a:spcPts val="1700"/>
+              </a:spcAft>
+              <a:defRPr sz="1900">
+                <a:solidFill>
+                  <a:srgbClr val="2D2D2D"/>
                 </a:solidFill>
               </a:defRPr>
             </a:pPr>
             <a:r>
-              <a:t>Bank Marketing Campaign Analysis  |  Exploratory Data Analysis</a:t>
+              <a:t>These are descriptive comparisons; they do not establish causation.</a:t>
             </a:r>
           </a:p>
         </p:txBody>
@@ -4430,57 +3879,14 @@
       <p:grpSpPr/>
       <p:sp>
         <p:nvSpPr>
-          <p:cNvPr id="2" name="Rectangle 1"/>
-          <p:cNvSpPr/>
-          <p:nvPr/>
-        </p:nvSpPr>
-        <p:spPr>
-          <a:xfrm>
-            <a:off x="0" y="0"/>
-            <a:ext cx="12191695" cy="1143000"/>
-          </a:xfrm>
-          <a:prstGeom prst="rect">
-            <a:avLst/>
-          </a:prstGeom>
-          <a:solidFill>
-            <a:srgbClr val="1F324E"/>
-          </a:solidFill>
-          <a:ln>
-            <a:noFill/>
-          </a:ln>
-        </p:spPr>
-        <p:style>
-          <a:lnRef idx="1">
-            <a:schemeClr val="accent1"/>
-          </a:lnRef>
-          <a:fillRef idx="3">
-            <a:schemeClr val="accent1"/>
-          </a:fillRef>
-          <a:effectRef idx="2">
-            <a:schemeClr val="accent1"/>
-          </a:effectRef>
-          <a:fontRef idx="minor">
-            <a:schemeClr val="lt1"/>
-          </a:fontRef>
-        </p:style>
-        <p:txBody>
-          <a:bodyPr rtlCol="0" anchor="ctr"/>
-          <a:lstStyle/>
-          <a:p>
-            <a:pPr algn="ctr"/>
-          </a:p>
-        </p:txBody>
-      </p:sp>
-      <p:sp>
-        <p:nvSpPr>
-          <p:cNvPr id="3" name="TextBox 2"/>
+          <p:cNvPr id="2" name="TextBox 1"/>
           <p:cNvSpPr txBox="1"/>
           <p:nvPr/>
         </p:nvSpPr>
         <p:spPr>
           <a:xfrm>
             <a:off x="502920" y="228600"/>
-            <a:ext cx="11155680" cy="640080"/>
+            <a:ext cx="11155680" cy="594360"/>
           </a:xfrm>
           <a:prstGeom prst="rect">
             <a:avLst/>
@@ -4496,26 +3902,26 @@
             <a:pPr>
               <a:defRPr sz="2700" b="1">
                 <a:solidFill>
-                  <a:srgbClr val="FFFFFF"/>
+                  <a:srgbClr val="1F3750"/>
                 </a:solidFill>
               </a:defRPr>
             </a:pPr>
             <a:r>
-              <a:t>Conclusion and Recommendations</a:t>
-            </a:r>
-          </a:p>
-        </p:txBody>
-      </p:sp>
-      <p:sp>
-        <p:nvSpPr>
-          <p:cNvPr id="4" name="TextBox 3"/>
+              <a:t>Conclusion &amp; Limitations</a:t>
+            </a:r>
+          </a:p>
+        </p:txBody>
+      </p:sp>
+      <p:sp>
+        <p:nvSpPr>
+          <p:cNvPr id="3" name="TextBox 2"/>
           <p:cNvSpPr txBox="1"/>
           <p:nvPr/>
         </p:nvSpPr>
         <p:spPr>
           <a:xfrm>
-            <a:off x="731520" y="1645920"/>
-            <a:ext cx="10789920" cy="4389120"/>
+            <a:off x="731520" y="1371600"/>
+            <a:ext cx="10789920" cy="4846320"/>
           </a:xfrm>
           <a:prstGeom prst="rect">
             <a:avLst/>
@@ -4530,96 +3936,76 @@
           <a:p>
             <a:pPr>
               <a:spcAft>
-                <a:spcPts val="1800"/>
+                <a:spcPts val="1700"/>
               </a:spcAft>
-              <a:defRPr sz="2100">
+              <a:defRPr sz="1800">
                 <a:solidFill>
                   <a:srgbClr val="2D2D2D"/>
                 </a:solidFill>
               </a:defRPr>
             </a:pPr>
             <a:r>
-              <a:t>Use subscription rates alongside customer counts to compare segments.</a:t>
+              <a:t>Overall subscription rate: 11.27%.</a:t>
             </a:r>
           </a:p>
           <a:p>
             <a:pPr>
               <a:spcAft>
-                <a:spcPts val="1800"/>
+                <a:spcPts val="1700"/>
               </a:spcAft>
-              <a:defRPr sz="2100">
+              <a:defRPr sz="1800">
                 <a:solidFill>
                   <a:srgbClr val="2D2D2D"/>
                 </a:solidFill>
               </a:defRPr>
             </a:pPr>
             <a:r>
-              <a:t>Review campaign outcomes and contact frequency before changing strategy.</a:t>
+              <a:t>Customer and campaign characteristics show differing subscription rates.</a:t>
             </a:r>
           </a:p>
           <a:p>
             <a:pPr>
               <a:spcAft>
-                <a:spcPts val="1800"/>
+                <a:spcPts val="1700"/>
               </a:spcAft>
-              <a:defRPr sz="2100">
+              <a:defRPr sz="1800">
                 <a:solidFill>
                   <a:srgbClr val="2D2D2D"/>
                 </a:solidFill>
               </a:defRPr>
             </a:pPr>
             <a:r>
-              <a:t>Validate findings on newer data before applying them to current campaigns.</a:t>
+              <a:t>The dataset contains 'unknown' category values; these are not automatically missing values.</a:t>
             </a:r>
           </a:p>
           <a:p>
             <a:pPr>
               <a:spcAft>
-                <a:spcPts val="1800"/>
+                <a:spcPts val="1700"/>
               </a:spcAft>
-              <a:defRPr sz="2100">
+              <a:defRPr sz="1800">
                 <a:solidFill>
                   <a:srgbClr val="2D2D2D"/>
                 </a:solidFill>
               </a:defRPr>
             </a:pPr>
             <a:r>
-              <a:t>Further analysis could evaluate customer targeting and campaign effectiveness.</a:t>
-            </a:r>
-          </a:p>
-        </p:txBody>
-      </p:sp>
-      <p:sp>
-        <p:nvSpPr>
-          <p:cNvPr id="5" name="TextBox 4"/>
-          <p:cNvSpPr txBox="1"/>
-          <p:nvPr/>
-        </p:nvSpPr>
-        <p:spPr>
-          <a:xfrm>
-            <a:off x="548640" y="6492240"/>
-            <a:ext cx="10972800" cy="182880"/>
-          </a:xfrm>
-          <a:prstGeom prst="rect">
-            <a:avLst/>
-          </a:prstGeom>
-          <a:noFill/>
-        </p:spPr>
-        <p:txBody>
-          <a:bodyPr wrap="none">
-            <a:spAutoFit/>
-          </a:bodyPr>
-          <a:lstStyle/>
+              <a:t>Call duration is known after the call, so it should not be used for pre-call targeting.</a:t>
+            </a:r>
+          </a:p>
           <a:p>
             <a:pPr>
-              <a:defRPr sz="900">
-                <a:solidFill>
-                  <a:srgbClr val="3769A0"/>
+              <a:spcAft>
+                <a:spcPts val="1700"/>
+              </a:spcAft>
+              <a:defRPr sz="1800">
+                <a:solidFill>
+                  <a:srgbClr val="2D2D2D"/>
                 </a:solidFill>
               </a:defRPr>
             </a:pPr>
             <a:r>
-              <a:t>Bank Marketing Campaign Analysis  |  Exploratory Data Analysis</a:t>
+              <a:t>Next step: validate potential campaign improvements with new data or controlled tests.</a:t>
             </a:r>
           </a:p>
         </p:txBody>

</xml_diff>